<commit_message>
docs: replace PowerShell paths with WSL (#85)
Co-Authored-By: Claude Sonnet 5.5 <noreply@anthropic.com>
</commit_message>
<xml_diff>
--- a/materials/slides/session-1.pptx
+++ b/materials/slides/session-1.pptx
@@ -6856,7 +6856,7 @@
                 </a:solidFill>
                 <a:latin typeface="Arial"/>
               </a:rPr>
-              <a:t>Expect all tests to pass; read failures and warnings. For </a:t>
+              <a:t>Expect all tests to pass; read failures and warnings. On </a:t>
             </a:r>
             <a:br/>
             <a:r>
@@ -6866,7 +6866,7 @@
                 </a:solidFill>
                 <a:latin typeface="Arial"/>
               </a:rPr>
-              <a:t>PowerShell equivalents, see </a:t>
+              <a:t>Windows, run in the WSL Ubuntu terminal: </a:t>
             </a:r>
             <a:r>
               <a:rPr sz="2100" b="0" i="0">
@@ -6876,7 +6876,7 @@
                 <a:latin typeface="Arial"/>
                 <a:hlinkClick r:id="rId2"/>
               </a:rPr>
-              <a:t>setup</a:t>
+              <a:t>Session 0</a:t>
             </a:r>
             <a:r>
               <a:rPr sz="2100" b="0" i="0">

</xml_diff>

<commit_message>
Reconcile two leftovers from the course restructure
The post-course survey still quoted 15 classroom hours; the course is now
14 hours 10 minutes. The Session 1 deck still sent students to the
standalone 3R-device-example repo, but the seven stage folders now live in
the Sandbox, which is how Sessions 2 and 3 already describe them.

Co-Authored-By: Claude Opus 5 <noreply@anthropic.com>
</commit_message>
<xml_diff>
--- a/materials/slides/session-1.pptx
+++ b/materials/slides/session-1.pptx
@@ -16154,7 +16154,25 @@
                 </a:solidFill>
                 <a:latin typeface="Arial"/>
               </a:rPr>
-              <a:t>curious: </a:t>
+              <a:t>curious: the </a:t>
+            </a:r>
+            <a:r>
+              <a:rPr sz="2100" b="0" i="0">
+                <a:solidFill>
+                  <a:srgbClr val="20344A"/>
+                </a:solidFill>
+                <a:latin typeface="Courier New"/>
+              </a:rPr>
+              <a:t>device-example</a:t>
+            </a:r>
+            <a:r>
+              <a:rPr sz="2100" b="0" i="0">
+                <a:solidFill>
+                  <a:srgbClr val="20344A"/>
+                </a:solidFill>
+                <a:latin typeface="Arial"/>
+              </a:rPr>
+              <a:t> folder of the </a:t>
             </a:r>
             <a:r>
               <a:rPr sz="2100" b="0" i="0">
@@ -16164,7 +16182,7 @@
                 <a:latin typeface="Arial"/>
                 <a:hlinkClick r:id="rId2"/>
               </a:rPr>
-              <a:t>3R-device-example</a:t>
+              <a:t>Sandbox</a:t>
             </a:r>
             <a:r>
               <a:rPr sz="2100" b="0" i="0">

</xml_diff>